<commit_message>
Reporte enviado en pptx 081026
</commit_message>
<xml_diff>
--- a/Reporte 081026.pptx
+++ b/Reporte 081026.pptx
@@ -5,7 +5,7 @@
     <p:sldMasterId id="2147483672" r:id="rId1"/>
   </p:sldMasterIdLst>
   <p:notesMasterIdLst>
-    <p:notesMasterId r:id="rId19"/>
+    <p:notesMasterId r:id="rId18"/>
   </p:notesMasterIdLst>
   <p:sldIdLst>
     <p:sldId id="350" r:id="rId2"/>
@@ -22,24 +22,23 @@
     <p:sldId id="361" r:id="rId13"/>
     <p:sldId id="412" r:id="rId14"/>
     <p:sldId id="371" r:id="rId15"/>
-    <p:sldId id="414" r:id="rId16"/>
-    <p:sldId id="413" r:id="rId17"/>
-    <p:sldId id="280" r:id="rId18"/>
+    <p:sldId id="413" r:id="rId16"/>
+    <p:sldId id="280" r:id="rId17"/>
   </p:sldIdLst>
   <p:sldSz cx="9144000" cy="5143500" type="screen16x9"/>
   <p:notesSz cx="6858000" cy="9144000"/>
   <p:embeddedFontLst>
     <p:embeddedFont>
       <p:font typeface="Montserrat" panose="00000500000000000000" pitchFamily="2" charset="0"/>
-      <p:regular r:id="rId20"/>
-      <p:bold r:id="rId21"/>
-      <p:italic r:id="rId22"/>
-      <p:boldItalic r:id="rId23"/>
+      <p:regular r:id="rId19"/>
+      <p:bold r:id="rId20"/>
+      <p:italic r:id="rId21"/>
+      <p:boldItalic r:id="rId22"/>
     </p:embeddedFont>
     <p:embeddedFont>
       <p:font typeface="Montserrat Black" panose="00000A00000000000000" pitchFamily="2" charset="0"/>
-      <p:bold r:id="rId24"/>
-      <p:boldItalic r:id="rId25"/>
+      <p:bold r:id="rId23"/>
+      <p:boldItalic r:id="rId24"/>
     </p:embeddedFont>
   </p:embeddedFontLst>
   <p:defaultTextStyle>
@@ -6551,10 +6550,10 @@
       </p:sp>
       <p:pic>
         <p:nvPicPr>
-          <p:cNvPr id="5" name="Imagen 4">
+          <p:cNvPr id="4" name="Imagen 3">
             <a:extLst>
               <a:ext uri="{FF2B5EF4-FFF2-40B4-BE49-F238E27FC236}">
-                <a16:creationId xmlns:a16="http://schemas.microsoft.com/office/drawing/2014/main" id="{22FBA1CB-772D-062C-639F-6E4F26AAE121}"/>
+                <a16:creationId xmlns:a16="http://schemas.microsoft.com/office/drawing/2014/main" id="{B7FE6A62-28F3-A756-8DA1-29E554B792F6}"/>
               </a:ext>
             </a:extLst>
           </p:cNvPr>
@@ -6571,8 +6570,8 @@
         </p:blipFill>
         <p:spPr>
           <a:xfrm>
-            <a:off x="-6725" y="501188"/>
-            <a:ext cx="9144000" cy="4284000"/>
+            <a:off x="0" y="633434"/>
+            <a:ext cx="9144000" cy="4019508"/>
           </a:xfrm>
           <a:prstGeom prst="rect">
             <a:avLst/>
@@ -6657,10 +6656,10 @@
       </p:sp>
       <p:pic>
         <p:nvPicPr>
-          <p:cNvPr id="3" name="Imagen 2">
+          <p:cNvPr id="4" name="Imagen 3">
             <a:extLst>
               <a:ext uri="{FF2B5EF4-FFF2-40B4-BE49-F238E27FC236}">
-                <a16:creationId xmlns:a16="http://schemas.microsoft.com/office/drawing/2014/main" id="{23F7C038-F150-8D45-9C76-9DF68A51FD54}"/>
+                <a16:creationId xmlns:a16="http://schemas.microsoft.com/office/drawing/2014/main" id="{8EB3F1C2-FFE4-FDD0-28AB-999C26D84881}"/>
               </a:ext>
             </a:extLst>
           </p:cNvPr>
@@ -6677,8 +6676,8 @@
         </p:blipFill>
         <p:spPr>
           <a:xfrm>
-            <a:off x="-6725" y="977856"/>
-            <a:ext cx="9144000" cy="3330664"/>
+            <a:off x="-6725" y="1173435"/>
+            <a:ext cx="9144000" cy="2939506"/>
           </a:xfrm>
           <a:prstGeom prst="rect">
             <a:avLst/>
@@ -6763,10 +6762,10 @@
       </p:sp>
       <p:pic>
         <p:nvPicPr>
-          <p:cNvPr id="4" name="Imagen 3">
+          <p:cNvPr id="5" name="Imagen 4">
             <a:extLst>
               <a:ext uri="{FF2B5EF4-FFF2-40B4-BE49-F238E27FC236}">
-                <a16:creationId xmlns:a16="http://schemas.microsoft.com/office/drawing/2014/main" id="{B2C26654-0903-0269-E83A-63766975CF5C}"/>
+                <a16:creationId xmlns:a16="http://schemas.microsoft.com/office/drawing/2014/main" id="{F5A74B4A-D376-35E8-AC69-70A3E5B39EF3}"/>
               </a:ext>
             </a:extLst>
           </p:cNvPr>
@@ -6783,8 +6782,8 @@
         </p:blipFill>
         <p:spPr>
           <a:xfrm>
-            <a:off x="0" y="369332"/>
-            <a:ext cx="9144000" cy="4582123"/>
+            <a:off x="0" y="861130"/>
+            <a:ext cx="9144000" cy="3564115"/>
           </a:xfrm>
           <a:prstGeom prst="rect">
             <a:avLst/>
@@ -6869,10 +6868,10 @@
       </p:sp>
       <p:pic>
         <p:nvPicPr>
-          <p:cNvPr id="3" name="Imagen 2">
+          <p:cNvPr id="7" name="Imagen 6">
             <a:extLst>
               <a:ext uri="{FF2B5EF4-FFF2-40B4-BE49-F238E27FC236}">
-                <a16:creationId xmlns:a16="http://schemas.microsoft.com/office/drawing/2014/main" id="{775607CF-B2CB-E7A6-19F9-B671185D6294}"/>
+                <a16:creationId xmlns:a16="http://schemas.microsoft.com/office/drawing/2014/main" id="{5F83A1B9-6C73-96C3-B224-CCAF6CF408D6}"/>
               </a:ext>
             </a:extLst>
           </p:cNvPr>
@@ -6889,8 +6888,8 @@
         </p:blipFill>
         <p:spPr>
           <a:xfrm>
-            <a:off x="0" y="961061"/>
-            <a:ext cx="9144000" cy="3364254"/>
+            <a:off x="0" y="1457477"/>
+            <a:ext cx="9144000" cy="2371422"/>
           </a:xfrm>
           <a:prstGeom prst="rect">
             <a:avLst/>
@@ -6975,10 +6974,10 @@
       </p:sp>
       <p:pic>
         <p:nvPicPr>
-          <p:cNvPr id="3" name="Imagen 2">
+          <p:cNvPr id="4" name="Imagen 3">
             <a:extLst>
               <a:ext uri="{FF2B5EF4-FFF2-40B4-BE49-F238E27FC236}">
-                <a16:creationId xmlns:a16="http://schemas.microsoft.com/office/drawing/2014/main" id="{FD7B2C57-5B34-3A73-5F6E-EAB69600A01A}"/>
+                <a16:creationId xmlns:a16="http://schemas.microsoft.com/office/drawing/2014/main" id="{6229E0CC-60D7-1807-E465-144AA6BD057C}"/>
               </a:ext>
             </a:extLst>
           </p:cNvPr>
@@ -6995,8 +6994,8 @@
         </p:blipFill>
         <p:spPr>
           <a:xfrm>
-            <a:off x="-1" y="463009"/>
-            <a:ext cx="9144000" cy="4360357"/>
+            <a:off x="0" y="679768"/>
+            <a:ext cx="9144000" cy="3926840"/>
           </a:xfrm>
           <a:prstGeom prst="rect">
             <a:avLst/>
@@ -7017,118 +7016,6 @@
 </file>
 
 <file path=ppt/slides/slide15.xml><?xml version="1.0" encoding="utf-8"?>
-<p:sld xmlns:a="http://schemas.openxmlformats.org/drawingml/2006/main" xmlns:r="http://schemas.openxmlformats.org/officeDocument/2006/relationships" xmlns:p="http://schemas.openxmlformats.org/presentationml/2006/main">
-  <p:cSld>
-    <p:bg>
-      <p:bgPr>
-        <a:solidFill>
-          <a:srgbClr val="F8F9FA"/>
-        </a:solidFill>
-        <a:effectLst/>
-      </p:bgPr>
-    </p:bg>
-    <p:spTree>
-      <p:nvGrpSpPr>
-        <p:cNvPr id="1" name="">
-          <a:extLst>
-            <a:ext uri="{FF2B5EF4-FFF2-40B4-BE49-F238E27FC236}">
-              <a16:creationId xmlns:a16="http://schemas.microsoft.com/office/drawing/2014/main" id="{91E945C0-F70E-13C6-898F-1A7B2C284705}"/>
-            </a:ext>
-          </a:extLst>
-        </p:cNvPr>
-        <p:cNvGrpSpPr/>
-        <p:nvPr/>
-      </p:nvGrpSpPr>
-      <p:grpSpPr>
-        <a:xfrm>
-          <a:off x="0" y="0"/>
-          <a:ext cx="0" cy="0"/>
-          <a:chOff x="0" y="0"/>
-          <a:chExt cx="0" cy="0"/>
-        </a:xfrm>
-      </p:grpSpPr>
-      <p:sp>
-        <p:nvSpPr>
-          <p:cNvPr id="6" name="CuadroTexto 5">
-            <a:extLst>
-              <a:ext uri="{FF2B5EF4-FFF2-40B4-BE49-F238E27FC236}">
-                <a16:creationId xmlns:a16="http://schemas.microsoft.com/office/drawing/2014/main" id="{A2BE0C88-EC1D-CCB4-1CC7-50C27412A870}"/>
-              </a:ext>
-            </a:extLst>
-          </p:cNvPr>
-          <p:cNvSpPr txBox="1"/>
-          <p:nvPr/>
-        </p:nvSpPr>
-        <p:spPr>
-          <a:xfrm>
-            <a:off x="1926166" y="88135"/>
-            <a:ext cx="5291667" cy="307777"/>
-          </a:xfrm>
-          <a:prstGeom prst="rect">
-            <a:avLst/>
-          </a:prstGeom>
-          <a:noFill/>
-        </p:spPr>
-        <p:txBody>
-          <a:bodyPr wrap="square" rtlCol="0">
-            <a:spAutoFit/>
-          </a:bodyPr>
-          <a:lstStyle/>
-          <a:p>
-            <a:pPr algn="ctr"/>
-            <a:r>
-              <a:rPr lang="es-MX" b="1" dirty="0">
-                <a:latin typeface="Montserrat" pitchFamily="2" charset="0"/>
-              </a:rPr>
-              <a:t>Temas de gobierno por radiodifusora</a:t>
-            </a:r>
-          </a:p>
-        </p:txBody>
-      </p:sp>
-      <p:pic>
-        <p:nvPicPr>
-          <p:cNvPr id="2" name="Imagen 1">
-            <a:extLst>
-              <a:ext uri="{FF2B5EF4-FFF2-40B4-BE49-F238E27FC236}">
-                <a16:creationId xmlns:a16="http://schemas.microsoft.com/office/drawing/2014/main" id="{16696B9A-1A9E-864A-E939-0E4E1011E90E}"/>
-              </a:ext>
-            </a:extLst>
-          </p:cNvPr>
-          <p:cNvPicPr>
-            <a:picLocks noChangeAspect="1"/>
-          </p:cNvPicPr>
-          <p:nvPr/>
-        </p:nvPicPr>
-        <p:blipFill>
-          <a:blip r:embed="rId2"/>
-          <a:stretch>
-            <a:fillRect/>
-          </a:stretch>
-        </p:blipFill>
-        <p:spPr>
-          <a:xfrm>
-            <a:off x="2000249" y="933450"/>
-            <a:ext cx="5143500" cy="3419475"/>
-          </a:xfrm>
-          <a:prstGeom prst="rect">
-            <a:avLst/>
-          </a:prstGeom>
-        </p:spPr>
-      </p:pic>
-    </p:spTree>
-    <p:extLst>
-      <p:ext uri="{BB962C8B-B14F-4D97-AF65-F5344CB8AC3E}">
-        <p14:creationId xmlns:p14="http://schemas.microsoft.com/office/powerpoint/2010/main" val="2812700958"/>
-      </p:ext>
-    </p:extLst>
-  </p:cSld>
-  <p:clrMapOvr>
-    <a:masterClrMapping/>
-  </p:clrMapOvr>
-</p:sld>
-</file>
-
-<file path=ppt/slides/slide16.xml><?xml version="1.0" encoding="utf-8"?>
 <p:sld xmlns:a="http://schemas.openxmlformats.org/drawingml/2006/main" xmlns:r="http://schemas.openxmlformats.org/officeDocument/2006/relationships" xmlns:p="http://schemas.openxmlformats.org/presentationml/2006/main">
   <p:cSld>
     <p:bg>
@@ -7199,10 +7086,10 @@
       </p:sp>
       <p:pic>
         <p:nvPicPr>
-          <p:cNvPr id="3" name="Imagen 2">
+          <p:cNvPr id="4" name="Imagen 3">
             <a:extLst>
               <a:ext uri="{FF2B5EF4-FFF2-40B4-BE49-F238E27FC236}">
-                <a16:creationId xmlns:a16="http://schemas.microsoft.com/office/drawing/2014/main" id="{9FBF71B3-4443-7E20-E0BE-0D37B688AC25}"/>
+                <a16:creationId xmlns:a16="http://schemas.microsoft.com/office/drawing/2014/main" id="{8C061178-A8AD-EF13-5670-0698456F3443}"/>
               </a:ext>
             </a:extLst>
           </p:cNvPr>
@@ -7219,8 +7106,8 @@
         </p:blipFill>
         <p:spPr>
           <a:xfrm>
-            <a:off x="-1" y="546758"/>
-            <a:ext cx="9144000" cy="4192859"/>
+            <a:off x="1486902" y="437734"/>
+            <a:ext cx="6097172" cy="4705766"/>
           </a:xfrm>
           <a:prstGeom prst="rect">
             <a:avLst/>
@@ -7240,7 +7127,7 @@
 </p:sld>
 </file>
 
-<file path=ppt/slides/slide17.xml><?xml version="1.0" encoding="utf-8"?>
+<file path=ppt/slides/slide16.xml><?xml version="1.0" encoding="utf-8"?>
 <p:sld xmlns:a="http://schemas.openxmlformats.org/drawingml/2006/main" xmlns:r="http://schemas.openxmlformats.org/officeDocument/2006/relationships" xmlns:p="http://schemas.openxmlformats.org/presentationml/2006/main">
   <p:cSld>
     <p:spTree>

</xml_diff>